<commit_message>
Status deck: bench diagnostic figure on sheet 5
Co-Authored-By: Claude Fable 5.1 <noreply@anthropic.com>
</commit_message>
<xml_diff>
--- a/docs/presentations/Group9_Status_2026-10-28.pptx
+++ b/docs/presentations/Group9_Status_2026-10-28.pptx
@@ -8997,16 +8997,86 @@
           </a:p>
         </p:txBody>
       </p:sp>
-      <p:sp>
-        <p:nvSpPr>
-          <p:cNvPr id="16" name="TextBox 15"/>
+      <p:pic>
+        <p:nvPicPr>
+          <p:cNvPr id="16" name="Picture 15" descr="g_lcddiag.png"/>
+          <p:cNvPicPr>
+            <a:picLocks noChangeAspect="1"/>
+          </p:cNvPicPr>
+          <p:nvPr/>
+        </p:nvPicPr>
+        <p:blipFill>
+          <a:blip r:embed="rId2"/>
+          <a:stretch>
+            <a:fillRect/>
+          </a:stretch>
+        </p:blipFill>
+        <p:spPr>
+          <a:xfrm>
+            <a:off x="502920" y="4206240"/>
+            <a:ext cx="5029200" cy="1865671"/>
+          </a:xfrm>
+          <a:prstGeom prst="rect">
+            <a:avLst/>
+          </a:prstGeom>
+        </p:spPr>
+      </p:pic>
+      <p:sp>
+        <p:nvSpPr>
+          <p:cNvPr id="17" name="Rectangle 16"/>
+          <p:cNvSpPr/>
+          <p:nvPr/>
+        </p:nvSpPr>
+        <p:spPr>
+          <a:xfrm>
+            <a:off x="5715000" y="4206240"/>
+            <a:ext cx="5989320" cy="1856231"/>
+          </a:xfrm>
+          <a:prstGeom prst="rect">
+            <a:avLst/>
+          </a:prstGeom>
+          <a:solidFill>
+            <a:srgbClr val="F2F5FA"/>
+          </a:solidFill>
+          <a:ln w="15875">
+            <a:solidFill>
+              <a:srgbClr val="5E6B85"/>
+            </a:solidFill>
+          </a:ln>
+          <a:effectLst/>
+        </p:spPr>
+        <p:style>
+          <a:lnRef idx="1">
+            <a:schemeClr val="accent1"/>
+          </a:lnRef>
+          <a:fillRef idx="3">
+            <a:schemeClr val="accent1"/>
+          </a:fillRef>
+          <a:effectRef idx="2">
+            <a:schemeClr val="accent1"/>
+          </a:effectRef>
+          <a:fontRef idx="minor">
+            <a:schemeClr val="lt1"/>
+          </a:fontRef>
+        </p:style>
+        <p:txBody>
+          <a:bodyPr rtlCol="0" anchor="ctr"/>
+          <a:lstStyle/>
+          <a:p>
+            <a:pPr algn="ctr"/>
+          </a:p>
+        </p:txBody>
+      </p:sp>
+      <p:sp>
+        <p:nvSpPr>
+          <p:cNvPr id="18" name="TextBox 17"/>
           <p:cNvSpPr txBox="1"/>
           <p:nvPr/>
         </p:nvSpPr>
         <p:spPr>
           <a:xfrm>
-            <a:off x="502920" y="4251960"/>
-            <a:ext cx="11155680" cy="822960"/>
+            <a:off x="5879592" y="4325112"/>
+            <a:ext cx="5660136" cy="1618487"/>
           </a:xfrm>
           <a:prstGeom prst="rect">
             <a:avLst/>
@@ -9019,15 +9089,30 @@
           </a:bodyPr>
           <a:lstStyle/>
           <a:p>
-            <a:pPr algn="l"/>
-            <a:r>
-              <a:rPr sz="1200" b="0" i="1">
+            <a:r>
+              <a:rPr sz="1250" b="1" spc="100">
                 <a:solidFill>
                   <a:srgbClr val="5E6B85"/>
                 </a:solidFill>
                 <a:latin typeface="Cambria"/>
               </a:rPr>
-              <a:t>Everything above is committed and pushed. The private repository holds the channel key, the config snapshots and the fix-1 firmware images; nothing with the key is public.</a:t>
+              <a:t>THE BENCH RECORD BEHIND THE 0.21 MI</a:t>
+            </a:r>
+          </a:p>
+          <a:p>
+            <a:pPr>
+              <a:spcBef>
+                <a:spcPts val="400"/>
+              </a:spcBef>
+            </a:pPr>
+            <a:r>
+              <a:rPr sz="1100">
+                <a:solidFill>
+                  <a:srgbClr val="222A3F"/>
+                </a:solidFill>
+                <a:latin typeface="Cambria"/>
+              </a:rPr>
+              <a:t>Parsed from both displays' serial logs on 24 October: clean boots, pairing in under 8 s, correct node tables, and SF's indoor GPS fix wandering 100 to 400 m between packets with phantom speed. The displays were right; the fixes were wrong. Everything on this sheet is committed and pushed; nothing with the channel key is public.</a:t>
             </a:r>
           </a:p>
         </p:txBody>

</xml_diff>